<commit_message>
test(patterns): neutral labels for the table-cell defPPr fixture text
The cell run and field no longer inherit red from defPPr, so "CELL INHERITS
RED" / "FIELD RED" misdescribed the fixture. Note in the spec that the
remaining defPPr character cascade is parser behaviour PowerPoint does not
share, tracked as a follow-up.

Co-Authored-By: Claude Opus 5.5 <noreply@anthropic.com>
(cherry picked from commit 0877d6da113edea565ad990378703fcd95003a42)
</commit_message>
<xml_diff>
--- a/tests/patterns/fixtures/pptx-run-inheritance.pptx
+++ b/tests/patterns/fixtures/pptx-run-inheritance.pptx
@@ -538,11 +538,11 @@
                       </a:pPr>
                       <a:r>
                         <a:rPr/>
-                        <a:t>CELL INHERITS RED</a:t>
+                        <a:t>CELL TEXT</a:t>
                       </a:r>
                       <a:fld id="{0FBB9679-570D-4509-9600-E07789CF24BB}" type="datetime">
                         <a:rPr/>
-                        <a:t> FIELD RED</a:t>
+                        <a:t> FIELD TEXT</a:t>
                       </a:fld>
                     </a:p>
                   </a:txBody>

</xml_diff>